<commit_message>
Almost Comleted for AI features
</commit_message>
<xml_diff>
--- a/examples/professional_demo/GOOGL_Financial_Analysis.pptx
+++ b/examples/professional_demo/GOOGL_Financial_Analysis.pptx
@@ -118,12 +118,36 @@
 <file path=ppt/charts/chart1.xml><?xml version="1.0" encoding="utf-8"?>
 <c:chartSpace xmlns:c="http://schemas.openxmlformats.org/drawingml/2006/chart" xmlns:a="http://schemas.openxmlformats.org/drawingml/2006/main" xmlns:r="http://schemas.openxmlformats.org/officeDocument/2006/relationships">
   <c:date1904 val="0"/>
+  <c:roundedCorners val="0"/>
   <c:chart>
+    <c:title>
+      <c:tx>
+        <c:rich>
+          <a:bodyPr/>
+          <a:lstStyle/>
+          <a:p>
+            <a:pPr>
+              <a:defRPr sz="2000" b="1">
+                <a:solidFill>
+                  <a:srgbClr val="192A56"/>
+                </a:solidFill>
+              </a:defRPr>
+            </a:pPr>
+            <a:r>
+              <a:t>Data Insights</a:t>
+            </a:r>
+          </a:p>
+        </c:rich>
+      </c:tx>
+      <c:layout/>
+      <c:overlay val="0"/>
+    </c:title>
     <c:autoTitleDeleted val="0"/>
     <c:plotArea>
-      <c:barChart>
-        <c:barDir val="col"/>
-        <c:grouping val="clustered"/>
+      <c:layout/>
+      <c:areaChart>
+        <c:grouping val="stacked"/>
+        <c:varyColors val="0"/>
         <c:ser>
           <c:idx val="0"/>
           <c:order val="0"/>
@@ -133,55 +157,66 @@
               <c:strCache>
                 <c:ptCount val="1"/>
                 <c:pt idx="0">
-                  <c:v>Values</c:v>
+                  <c:v>MarketCap</c:v>
                 </c:pt>
               </c:strCache>
             </c:strRef>
           </c:tx>
+          <c:spPr>
+            <a:solidFill>
+              <a:srgbClr val="2980B9"/>
+            </a:solidFill>
+          </c:spPr>
           <c:cat>
             <c:strRef>
-              <c:f>Sheet1!$A$2:$A$11</c:f>
+              <c:f>Sheet1!$A$2:$A$13</c:f>
               <c:strCache>
-                <c:ptCount val="10"/>
+                <c:ptCount val="12"/>
                 <c:pt idx="0">
-                  <c:v>Item 1</c:v>
+                  <c:v>AAPL</c:v>
                 </c:pt>
                 <c:pt idx="1">
-                  <c:v>Item 2</c:v>
+                  <c:v>MSFT</c:v>
                 </c:pt>
                 <c:pt idx="2">
-                  <c:v>Item 3</c:v>
+                  <c:v>GOOGL</c:v>
                 </c:pt>
                 <c:pt idx="3">
-                  <c:v>Item 4</c:v>
+                  <c:v>AMZN</c:v>
                 </c:pt>
                 <c:pt idx="4">
-                  <c:v>Item 5</c:v>
+                  <c:v>TSLA</c:v>
                 </c:pt>
                 <c:pt idx="5">
-                  <c:v>Item 6</c:v>
+                  <c:v>nan</c:v>
                 </c:pt>
                 <c:pt idx="6">
-                  <c:v>Item 7</c:v>
+                  <c:v>nan</c:v>
                 </c:pt>
                 <c:pt idx="7">
-                  <c:v>Item 8</c:v>
+                  <c:v>nan</c:v>
                 </c:pt>
                 <c:pt idx="8">
-                  <c:v>Item 9</c:v>
+                  <c:v>nan</c:v>
                 </c:pt>
                 <c:pt idx="9">
-                  <c:v>Item 10</c:v>
+                  <c:v>nan</c:v>
+                </c:pt>
+                <c:pt idx="10">
+                  <c:v>nan</c:v>
+                </c:pt>
+                <c:pt idx="11">
+                  <c:v>nan</c:v>
                 </c:pt>
               </c:strCache>
             </c:strRef>
           </c:cat>
           <c:val>
             <c:numRef>
-              <c:f>Sheet1!$B$2:$B$11</c:f>
+              <c:f>Sheet1!$B$2:$B$13</c:f>
               <c:numCache>
                 <c:formatCode>General</c:formatCode>
-                <c:ptCount val="10"/>
+                <c:ptCount val="12"/>
                 <c:pt idx="0">
                   <c:v>4027681603584.0</c:v>
                 </c:pt>
@@ -210,26 +245,259 @@
                   <c:v>0.0</c:v>
                 </c:pt>
                 <c:pt idx="9">
+                  <c:v>0.0</c:v>
+                </c:pt>
+                <c:pt idx="10">
+                  <c:v>0.0</c:v>
+                </c:pt>
+                <c:pt idx="11">
                   <c:v>0.0</c:v>
                 </c:pt>
               </c:numCache>
             </c:numRef>
           </c:val>
         </c:ser>
-        <c:axId val="-2068027336"/>
-        <c:axId val="-2113994440"/>
-      </c:barChart>
+        <c:ser>
+          <c:idx val="1"/>
+          <c:order val="1"/>
+          <c:tx>
+            <c:strRef>
+              <c:f>Sheet1!$C$1</c:f>
+              <c:strCache>
+                <c:ptCount val="1"/>
+                <c:pt idx="0">
+                  <c:v>CurrentPrice</c:v>
+                </c:pt>
+              </c:strCache>
+            </c:strRef>
+          </c:tx>
+          <c:spPr>
+            <a:solidFill>
+              <a:srgbClr val="27AE60"/>
+            </a:solidFill>
+          </c:spPr>
+          <c:cat>
+            <c:strRef>
+              <c:f>Sheet1!$A$2:$A$13</c:f>
+              <c:strCache>
+                <c:ptCount val="12"/>
+                <c:pt idx="0">
+                  <c:v>AAPL</c:v>
+                </c:pt>
+                <c:pt idx="1">
+                  <c:v>MSFT</c:v>
+                </c:pt>
+                <c:pt idx="2">
+                  <c:v>GOOGL</c:v>
+                </c:pt>
+                <c:pt idx="3">
+                  <c:v>AMZN</c:v>
+                </c:pt>
+                <c:pt idx="4">
+                  <c:v>TSLA</c:v>
+                </c:pt>
+                <c:pt idx="5">
+                  <c:v>nan</c:v>
+                </c:pt>
+                <c:pt idx="6">
+                  <c:v>nan</c:v>
+                </c:pt>
+                <c:pt idx="7">
+                  <c:v>nan</c:v>
+                </c:pt>
+                <c:pt idx="8">
+                  <c:v>nan</c:v>
+                </c:pt>
+                <c:pt idx="9">
+                  <c:v>nan</c:v>
+                </c:pt>
+                <c:pt idx="10">
+                  <c:v>nan</c:v>
+                </c:pt>
+                <c:pt idx="11">
+                  <c:v>nan</c:v>
+                </c:pt>
+              </c:strCache>
+            </c:strRef>
+          </c:cat>
+          <c:val>
+            <c:numRef>
+              <c:f>Sheet1!$C$2:$C$13</c:f>
+              <c:numCache>
+                <c:formatCode>General</c:formatCode>
+                <c:ptCount val="12"/>
+                <c:pt idx="0">
+                  <c:v>270.37</c:v>
+                </c:pt>
+                <c:pt idx="1">
+                  <c:v>517.81</c:v>
+                </c:pt>
+                <c:pt idx="2">
+                  <c:v>281.19</c:v>
+                </c:pt>
+                <c:pt idx="3">
+                  <c:v>244.22</c:v>
+                </c:pt>
+                <c:pt idx="4">
+                  <c:v>456.56</c:v>
+                </c:pt>
+                <c:pt idx="5">
+                  <c:v>0.0</c:v>
+                </c:pt>
+                <c:pt idx="6">
+                  <c:v>0.0</c:v>
+                </c:pt>
+                <c:pt idx="7">
+                  <c:v>0.0</c:v>
+                </c:pt>
+                <c:pt idx="8">
+                  <c:v>0.0</c:v>
+                </c:pt>
+                <c:pt idx="9">
+                  <c:v>0.0</c:v>
+                </c:pt>
+                <c:pt idx="10">
+                  <c:v>0.0</c:v>
+                </c:pt>
+                <c:pt idx="11">
+                  <c:v>0.0</c:v>
+                </c:pt>
+              </c:numCache>
+            </c:numRef>
+          </c:val>
+        </c:ser>
+        <c:ser>
+          <c:idx val="2"/>
+          <c:order val="2"/>
+          <c:tx>
+            <c:strRef>
+              <c:f>Sheet1!$D$1</c:f>
+              <c:strCache>
+                <c:ptCount val="1"/>
+                <c:pt idx="0">
+                  <c:v>TrailingPE</c:v>
+                </c:pt>
+              </c:strCache>
+            </c:strRef>
+          </c:tx>
+          <c:spPr>
+            <a:solidFill>
+              <a:srgbClr val="E67E22"/>
+            </a:solidFill>
+          </c:spPr>
+          <c:cat>
+            <c:strRef>
+              <c:f>Sheet1!$A$2:$A$13</c:f>
+              <c:strCache>
+                <c:ptCount val="12"/>
+                <c:pt idx="0">
+                  <c:v>AAPL</c:v>
+                </c:pt>
+                <c:pt idx="1">
+                  <c:v>MSFT</c:v>
+                </c:pt>
+                <c:pt idx="2">
+                  <c:v>GOOGL</c:v>
+                </c:pt>
+                <c:pt idx="3">
+                  <c:v>AMZN</c:v>
+                </c:pt>
+                <c:pt idx="4">
+                  <c:v>TSLA</c:v>
+                </c:pt>
+                <c:pt idx="5">
+                  <c:v>nan</c:v>
+                </c:pt>
+                <c:pt idx="6">
+                  <c:v>nan</c:v>
+                </c:pt>
+                <c:pt idx="7">
+                  <c:v>nan</c:v>
+                </c:pt>
+                <c:pt idx="8">
+                  <c:v>nan</c:v>
+                </c:pt>
+                <c:pt idx="9">
+                  <c:v>nan</c:v>
+                </c:pt>
+                <c:pt idx="10">
+                  <c:v>nan</c:v>
+                </c:pt>
+                <c:pt idx="11">
+                  <c:v>nan</c:v>
+                </c:pt>
+              </c:strCache>
+            </c:strRef>
+          </c:cat>
+          <c:val>
+            <c:numRef>
+              <c:f>Sheet1!$D$2:$D$13</c:f>
+              <c:numCache>
+                <c:formatCode>General</c:formatCode>
+                <c:ptCount val="12"/>
+                <c:pt idx="0">
+                  <c:v>36.24</c:v>
+                </c:pt>
+                <c:pt idx="1">
+                  <c:v>36.78</c:v>
+                </c:pt>
+                <c:pt idx="2">
+                  <c:v>27.79</c:v>
+                </c:pt>
+                <c:pt idx="3">
+                  <c:v>34.49</c:v>
+                </c:pt>
+                <c:pt idx="4">
+                  <c:v>312.71</c:v>
+                </c:pt>
+                <c:pt idx="5">
+                  <c:v>0.0</c:v>
+                </c:pt>
+                <c:pt idx="6">
+                  <c:v>0.0</c:v>
+                </c:pt>
+                <c:pt idx="7">
+                  <c:v>0.0</c:v>
+                </c:pt>
+                <c:pt idx="8">
+                  <c:v>0.0</c:v>
+                </c:pt>
+                <c:pt idx="9">
+                  <c:v>0.0</c:v>
+                </c:pt>
+                <c:pt idx="10">
+                  <c:v>0.0</c:v>
+                </c:pt>
+                <c:pt idx="11">
+                  <c:v>0.0</c:v>
+                </c:pt>
+              </c:numCache>
+            </c:numRef>
+          </c:val>
+        </c:ser>
+        <c:dLbls>
+          <c:showLegendKey val="0"/>
+          <c:showVal val="0"/>
+          <c:showCatName val="0"/>
+          <c:showSerName val="0"/>
+          <c:showPercent val="0"/>
+          <c:showBubbleSize val="0"/>
+        </c:dLbls>
+        <c:axId val="-2101159928"/>
+        <c:axId val="-2100718248"/>
+      </c:areaChart>
       <c:catAx>
-        <c:axId val="-2068027336"/>
+        <c:axId val="-2101159928"/>
         <c:scaling>
           <c:orientation val="minMax"/>
         </c:scaling>
         <c:delete val="0"/>
         <c:axPos val="b"/>
+        <c:numFmt formatCode="General" sourceLinked="1"/>
         <c:majorTickMark val="out"/>
         <c:minorTickMark val="none"/>
         <c:tickLblPos val="nextTo"/>
-        <c:crossAx val="-2113994440"/>
+        <c:crossAx val="-2100718248"/>
         <c:crosses val="autoZero"/>
         <c:auto val="1"/>
         <c:lblAlgn val="ctr"/>
@@ -237,19 +505,39 @@
         <c:noMultiLvlLbl val="0"/>
       </c:catAx>
       <c:valAx>
-        <c:axId val="-2113994440"/>
-        <c:scaling/>
+        <c:axId val="-2100718248"/>
+        <c:scaling>
+          <c:orientation val="minMax"/>
+        </c:scaling>
         <c:delete val="0"/>
         <c:axPos val="l"/>
         <c:majorGridlines/>
+        <c:numFmt formatCode="General" sourceLinked="1"/>
         <c:majorTickMark val="out"/>
         <c:minorTickMark val="none"/>
         <c:tickLblPos val="nextTo"/>
-        <c:crossAx val="-2068027336"/>
+        <c:crossAx val="-2101159928"/>
         <c:crosses val="autoZero"/>
+        <c:crossBetween val="midCat"/>
       </c:valAx>
     </c:plotArea>
-    <c:dispBlanksAs val="gap"/>
+    <c:legend>
+      <c:legendPos val="b"/>
+      <c:layout/>
+      <c:overlay val="0"/>
+      <c:txPr>
+        <a:bodyPr/>
+        <a:lstStyle/>
+        <a:p>
+          <a:pPr>
+            <a:defRPr sz="1100" b="0"/>
+          </a:pPr>
+        </a:p>
+      </c:txPr>
+    </c:legend>
+    <c:plotVisOnly val="1"/>
+    <c:dispBlanksAs val="zero"/>
+    <c:showDLblsOverMax val="0"/>
   </c:chart>
   <c:txPr>
     <a:bodyPr/>
@@ -258,7 +546,7 @@
       <a:pPr>
         <a:defRPr sz="1800"/>
       </a:pPr>
-      <a:endParaRPr lang="en-US"/>
+      <a:endParaRPr/>
     </a:p>
   </c:txPr>
   <c:externalData r:id="rId1">
@@ -278,7 +566,11 @@
           <a:lstStyle/>
           <a:p>
             <a:pPr>
-              <a:defRPr sz="1800" b="1"/>
+              <a:defRPr sz="2000" b="1">
+                <a:solidFill>
+                  <a:srgbClr val="192A56"/>
+                </a:solidFill>
+              </a:defRPr>
             </a:pPr>
             <a:r>
               <a:t>Sector Distribution</a:t>
@@ -292,7 +584,7 @@
     <c:autoTitleDeleted val="0"/>
     <c:plotArea>
       <c:barChart>
-        <c:barDir val="col"/>
+        <c:barDir val="bar"/>
         <c:grouping val="clustered"/>
         <c:ser>
           <c:idx val="0"/>
@@ -308,6 +600,11 @@
               </c:strCache>
             </c:strRef>
           </c:tx>
+          <c:spPr>
+            <a:solidFill>
+              <a:srgbClr val="2980B9"/>
+            </a:solidFill>
+          </c:spPr>
           <c:cat>
             <c:strRef>
               <c:f>Sheet1!$A$2:$A$6</c:f>
@@ -356,6 +653,26 @@
             </c:numRef>
           </c:val>
         </c:ser>
+        <c:dLbls>
+          <c:numFmt formatCode="#,##0" sourceLinked="0"/>
+          <c:txPr>
+            <a:bodyPr/>
+            <a:lstStyle/>
+            <a:p>
+              <a:pPr>
+                <a:defRPr sz="900" b="1"/>
+              </a:pPr>
+            </a:p>
+          </c:txPr>
+          <c:dLblPos val="outEnd"/>
+          <c:showLegendKey val="0"/>
+          <c:showVal val="1"/>
+          <c:showCatName val="0"/>
+          <c:showSerName val="0"/>
+          <c:showPercent val="0"/>
+          <c:showBubbleSize val="0"/>
+          <c:showLeaderLines val="1"/>
+        </c:dLbls>
         <c:axId val="-2068027336"/>
         <c:axId val="-2113994440"/>
       </c:barChart>
@@ -365,7 +682,7 @@
           <c:orientation val="minMax"/>
         </c:scaling>
         <c:delete val="0"/>
-        <c:axPos val="b"/>
+        <c:axPos val="l"/>
         <c:majorTickMark val="out"/>
         <c:minorTickMark val="none"/>
         <c:tickLblPos val="nextTo"/>
@@ -380,7 +697,7 @@
         <c:axId val="-2113994440"/>
         <c:scaling/>
         <c:delete val="0"/>
-        <c:axPos val="l"/>
+        <c:axPos val="b"/>
         <c:majorGridlines/>
         <c:majorTickMark val="out"/>
         <c:minorTickMark val="none"/>
@@ -396,7 +713,7 @@
         <a:lstStyle/>
         <a:p>
           <a:pPr>
-            <a:defRPr sz="1000"/>
+            <a:defRPr sz="1100" b="0"/>
           </a:pPr>
         </a:p>
       </c:txPr>
@@ -422,12 +739,36 @@
 <file path=ppt/charts/chart3.xml><?xml version="1.0" encoding="utf-8"?>
 <c:chartSpace xmlns:c="http://schemas.openxmlformats.org/drawingml/2006/chart" xmlns:a="http://schemas.openxmlformats.org/drawingml/2006/main" xmlns:r="http://schemas.openxmlformats.org/officeDocument/2006/relationships">
   <c:date1904 val="0"/>
+  <c:roundedCorners val="0"/>
   <c:chart>
+    <c:title>
+      <c:tx>
+        <c:rich>
+          <a:bodyPr/>
+          <a:lstStyle/>
+          <a:p>
+            <a:pPr>
+              <a:defRPr sz="2000" b="1">
+                <a:solidFill>
+                  <a:srgbClr val="192A56"/>
+                </a:solidFill>
+              </a:defRPr>
+            </a:pPr>
+            <a:r>
+              <a:t>Trend Analysis</a:t>
+            </a:r>
+          </a:p>
+        </c:rich>
+      </c:tx>
+      <c:layout/>
+      <c:overlay val="0"/>
+    </c:title>
     <c:autoTitleDeleted val="0"/>
     <c:plotArea>
-      <c:barChart>
-        <c:barDir val="col"/>
-        <c:grouping val="clustered"/>
+      <c:layout/>
+      <c:areaChart>
+        <c:grouping val="stacked"/>
+        <c:varyColors val="0"/>
         <c:ser>
           <c:idx val="0"/>
           <c:order val="0"/>
@@ -437,55 +778,66 @@
               <c:strCache>
                 <c:ptCount val="1"/>
                 <c:pt idx="0">
-                  <c:v>Values</c:v>
+                  <c:v>MarketCap</c:v>
                 </c:pt>
               </c:strCache>
             </c:strRef>
           </c:tx>
+          <c:spPr>
+            <a:solidFill>
+              <a:srgbClr val="2980B9"/>
+            </a:solidFill>
+          </c:spPr>
           <c:cat>
             <c:strRef>
-              <c:f>Sheet1!$A$2:$A$11</c:f>
+              <c:f>Sheet1!$A$2:$A$13</c:f>
               <c:strCache>
-                <c:ptCount val="10"/>
+                <c:ptCount val="12"/>
                 <c:pt idx="0">
-                  <c:v>Item 1</c:v>
+                  <c:v>AAPL</c:v>
                 </c:pt>
                 <c:pt idx="1">
-                  <c:v>Item 2</c:v>
+                  <c:v>MSFT</c:v>
                 </c:pt>
                 <c:pt idx="2">
-                  <c:v>Item 3</c:v>
+                  <c:v>GOOGL</c:v>
                 </c:pt>
                 <c:pt idx="3">
-                  <c:v>Item 4</c:v>
+                  <c:v>AMZN</c:v>
                 </c:pt>
                 <c:pt idx="4">
-                  <c:v>Item 5</c:v>
+                  <c:v>TSLA</c:v>
                 </c:pt>
                 <c:pt idx="5">
-                  <c:v>Item 6</c:v>
+                  <c:v>nan</c:v>
                 </c:pt>
                 <c:pt idx="6">
-                  <c:v>Item 7</c:v>
+                  <c:v>nan</c:v>
                 </c:pt>
                 <c:pt idx="7">
-                  <c:v>Item 8</c:v>
+                  <c:v>nan</c:v>
                 </c:pt>
                 <c:pt idx="8">
-                  <c:v>Item 9</c:v>
+                  <c:v>nan</c:v>
                 </c:pt>
                 <c:pt idx="9">
-                  <c:v>Item 10</c:v>
+                  <c:v>nan</c:v>
+                </c:pt>
+                <c:pt idx="10">
+                  <c:v>nan</c:v>
+                </c:pt>
+                <c:pt idx="11">
+                  <c:v>nan</c:v>
                 </c:pt>
               </c:strCache>
             </c:strRef>
           </c:cat>
           <c:val>
             <c:numRef>
-              <c:f>Sheet1!$B$2:$B$11</c:f>
+              <c:f>Sheet1!$B$2:$B$13</c:f>
               <c:numCache>
                 <c:formatCode>General</c:formatCode>
-                <c:ptCount val="10"/>
+                <c:ptCount val="12"/>
                 <c:pt idx="0">
                   <c:v>4027681603584.0</c:v>
                 </c:pt>
@@ -514,26 +866,259 @@
                   <c:v>0.0</c:v>
                 </c:pt>
                 <c:pt idx="9">
+                  <c:v>0.0</c:v>
+                </c:pt>
+                <c:pt idx="10">
+                  <c:v>0.0</c:v>
+                </c:pt>
+                <c:pt idx="11">
                   <c:v>0.0</c:v>
                 </c:pt>
               </c:numCache>
             </c:numRef>
           </c:val>
         </c:ser>
-        <c:axId val="-2068027336"/>
-        <c:axId val="-2113994440"/>
-      </c:barChart>
+        <c:ser>
+          <c:idx val="1"/>
+          <c:order val="1"/>
+          <c:tx>
+            <c:strRef>
+              <c:f>Sheet1!$C$1</c:f>
+              <c:strCache>
+                <c:ptCount val="1"/>
+                <c:pt idx="0">
+                  <c:v>CurrentPrice</c:v>
+                </c:pt>
+              </c:strCache>
+            </c:strRef>
+          </c:tx>
+          <c:spPr>
+            <a:solidFill>
+              <a:srgbClr val="27AE60"/>
+            </a:solidFill>
+          </c:spPr>
+          <c:cat>
+            <c:strRef>
+              <c:f>Sheet1!$A$2:$A$13</c:f>
+              <c:strCache>
+                <c:ptCount val="12"/>
+                <c:pt idx="0">
+                  <c:v>AAPL</c:v>
+                </c:pt>
+                <c:pt idx="1">
+                  <c:v>MSFT</c:v>
+                </c:pt>
+                <c:pt idx="2">
+                  <c:v>GOOGL</c:v>
+                </c:pt>
+                <c:pt idx="3">
+                  <c:v>AMZN</c:v>
+                </c:pt>
+                <c:pt idx="4">
+                  <c:v>TSLA</c:v>
+                </c:pt>
+                <c:pt idx="5">
+                  <c:v>nan</c:v>
+                </c:pt>
+                <c:pt idx="6">
+                  <c:v>nan</c:v>
+                </c:pt>
+                <c:pt idx="7">
+                  <c:v>nan</c:v>
+                </c:pt>
+                <c:pt idx="8">
+                  <c:v>nan</c:v>
+                </c:pt>
+                <c:pt idx="9">
+                  <c:v>nan</c:v>
+                </c:pt>
+                <c:pt idx="10">
+                  <c:v>nan</c:v>
+                </c:pt>
+                <c:pt idx="11">
+                  <c:v>nan</c:v>
+                </c:pt>
+              </c:strCache>
+            </c:strRef>
+          </c:cat>
+          <c:val>
+            <c:numRef>
+              <c:f>Sheet1!$C$2:$C$13</c:f>
+              <c:numCache>
+                <c:formatCode>General</c:formatCode>
+                <c:ptCount val="12"/>
+                <c:pt idx="0">
+                  <c:v>270.37</c:v>
+                </c:pt>
+                <c:pt idx="1">
+                  <c:v>517.81</c:v>
+                </c:pt>
+                <c:pt idx="2">
+                  <c:v>281.19</c:v>
+                </c:pt>
+                <c:pt idx="3">
+                  <c:v>244.22</c:v>
+                </c:pt>
+                <c:pt idx="4">
+                  <c:v>456.56</c:v>
+                </c:pt>
+                <c:pt idx="5">
+                  <c:v>0.0</c:v>
+                </c:pt>
+                <c:pt idx="6">
+                  <c:v>0.0</c:v>
+                </c:pt>
+                <c:pt idx="7">
+                  <c:v>0.0</c:v>
+                </c:pt>
+                <c:pt idx="8">
+                  <c:v>0.0</c:v>
+                </c:pt>
+                <c:pt idx="9">
+                  <c:v>0.0</c:v>
+                </c:pt>
+                <c:pt idx="10">
+                  <c:v>0.0</c:v>
+                </c:pt>
+                <c:pt idx="11">
+                  <c:v>0.0</c:v>
+                </c:pt>
+              </c:numCache>
+            </c:numRef>
+          </c:val>
+        </c:ser>
+        <c:ser>
+          <c:idx val="2"/>
+          <c:order val="2"/>
+          <c:tx>
+            <c:strRef>
+              <c:f>Sheet1!$D$1</c:f>
+              <c:strCache>
+                <c:ptCount val="1"/>
+                <c:pt idx="0">
+                  <c:v>TrailingPE</c:v>
+                </c:pt>
+              </c:strCache>
+            </c:strRef>
+          </c:tx>
+          <c:spPr>
+            <a:solidFill>
+              <a:srgbClr val="E67E22"/>
+            </a:solidFill>
+          </c:spPr>
+          <c:cat>
+            <c:strRef>
+              <c:f>Sheet1!$A$2:$A$13</c:f>
+              <c:strCache>
+                <c:ptCount val="12"/>
+                <c:pt idx="0">
+                  <c:v>AAPL</c:v>
+                </c:pt>
+                <c:pt idx="1">
+                  <c:v>MSFT</c:v>
+                </c:pt>
+                <c:pt idx="2">
+                  <c:v>GOOGL</c:v>
+                </c:pt>
+                <c:pt idx="3">
+                  <c:v>AMZN</c:v>
+                </c:pt>
+                <c:pt idx="4">
+                  <c:v>TSLA</c:v>
+                </c:pt>
+                <c:pt idx="5">
+                  <c:v>nan</c:v>
+                </c:pt>
+                <c:pt idx="6">
+                  <c:v>nan</c:v>
+                </c:pt>
+                <c:pt idx="7">
+                  <c:v>nan</c:v>
+                </c:pt>
+                <c:pt idx="8">
+                  <c:v>nan</c:v>
+                </c:pt>
+                <c:pt idx="9">
+                  <c:v>nan</c:v>
+                </c:pt>
+                <c:pt idx="10">
+                  <c:v>nan</c:v>
+                </c:pt>
+                <c:pt idx="11">
+                  <c:v>nan</c:v>
+                </c:pt>
+              </c:strCache>
+            </c:strRef>
+          </c:cat>
+          <c:val>
+            <c:numRef>
+              <c:f>Sheet1!$D$2:$D$13</c:f>
+              <c:numCache>
+                <c:formatCode>General</c:formatCode>
+                <c:ptCount val="12"/>
+                <c:pt idx="0">
+                  <c:v>36.24</c:v>
+                </c:pt>
+                <c:pt idx="1">
+                  <c:v>36.78</c:v>
+                </c:pt>
+                <c:pt idx="2">
+                  <c:v>27.79</c:v>
+                </c:pt>
+                <c:pt idx="3">
+                  <c:v>34.49</c:v>
+                </c:pt>
+                <c:pt idx="4">
+                  <c:v>312.71</c:v>
+                </c:pt>
+                <c:pt idx="5">
+                  <c:v>0.0</c:v>
+                </c:pt>
+                <c:pt idx="6">
+                  <c:v>0.0</c:v>
+                </c:pt>
+                <c:pt idx="7">
+                  <c:v>0.0</c:v>
+                </c:pt>
+                <c:pt idx="8">
+                  <c:v>0.0</c:v>
+                </c:pt>
+                <c:pt idx="9">
+                  <c:v>0.0</c:v>
+                </c:pt>
+                <c:pt idx="10">
+                  <c:v>0.0</c:v>
+                </c:pt>
+                <c:pt idx="11">
+                  <c:v>0.0</c:v>
+                </c:pt>
+              </c:numCache>
+            </c:numRef>
+          </c:val>
+        </c:ser>
+        <c:dLbls>
+          <c:showLegendKey val="0"/>
+          <c:showVal val="0"/>
+          <c:showCatName val="0"/>
+          <c:showSerName val="0"/>
+          <c:showPercent val="0"/>
+          <c:showBubbleSize val="0"/>
+        </c:dLbls>
+        <c:axId val="-2101159928"/>
+        <c:axId val="-2100718248"/>
+      </c:areaChart>
       <c:catAx>
-        <c:axId val="-2068027336"/>
+        <c:axId val="-2101159928"/>
         <c:scaling>
           <c:orientation val="minMax"/>
         </c:scaling>
         <c:delete val="0"/>
         <c:axPos val="b"/>
+        <c:numFmt formatCode="General" sourceLinked="1"/>
         <c:majorTickMark val="out"/>
         <c:minorTickMark val="none"/>
         <c:tickLblPos val="nextTo"/>
-        <c:crossAx val="-2113994440"/>
+        <c:crossAx val="-2100718248"/>
         <c:crosses val="autoZero"/>
         <c:auto val="1"/>
         <c:lblAlgn val="ctr"/>
@@ -541,19 +1126,39 @@
         <c:noMultiLvlLbl val="0"/>
       </c:catAx>
       <c:valAx>
-        <c:axId val="-2113994440"/>
-        <c:scaling/>
+        <c:axId val="-2100718248"/>
+        <c:scaling>
+          <c:orientation val="minMax"/>
+        </c:scaling>
         <c:delete val="0"/>
         <c:axPos val="l"/>
         <c:majorGridlines/>
+        <c:numFmt formatCode="General" sourceLinked="1"/>
         <c:majorTickMark val="out"/>
         <c:minorTickMark val="none"/>
         <c:tickLblPos val="nextTo"/>
-        <c:crossAx val="-2068027336"/>
+        <c:crossAx val="-2101159928"/>
         <c:crosses val="autoZero"/>
+        <c:crossBetween val="midCat"/>
       </c:valAx>
     </c:plotArea>
-    <c:dispBlanksAs val="gap"/>
+    <c:legend>
+      <c:legendPos val="b"/>
+      <c:layout/>
+      <c:overlay val="0"/>
+      <c:txPr>
+        <a:bodyPr/>
+        <a:lstStyle/>
+        <a:p>
+          <a:pPr>
+            <a:defRPr sz="1100" b="0"/>
+          </a:pPr>
+        </a:p>
+      </c:txPr>
+    </c:legend>
+    <c:plotVisOnly val="1"/>
+    <c:dispBlanksAs val="zero"/>
+    <c:showDLblsOverMax val="0"/>
   </c:chart>
   <c:txPr>
     <a:bodyPr/>
@@ -562,7 +1167,7 @@
       <a:pPr>
         <a:defRPr sz="1800"/>
       </a:pPr>
-      <a:endParaRPr lang="en-US"/>
+      <a:endParaRPr/>
     </a:p>
   </c:txPr>
   <c:externalData r:id="rId1">

</xml_diff>